<commit_message>
Build source-native family benchmark chain
</commit_message>
<xml_diff>
--- a/output/pptx/LumenCore_Evidence_to_Pilot_Deck_CURRENT_REVIEW_REQUIRED.pptx
+++ b/output/pptx/LumenCore_Evidence_to_Pilot_Deck_CURRENT_REVIEW_REQUIRED.pptx
@@ -2,23 +2,23 @@
 <file path=ppt/presentation.xml><?xml version="1.0" encoding="utf-8"?>
 <p:presentation xmlns:p="http://schemas.openxmlformats.org/presentationml/2006/main">
   <p:sldMasterIdLst>
-    <p:sldMasterId xmlns:r="http://schemas.openxmlformats.org/officeDocument/2006/relationships" id="2147483648" r:id="R3959446cef4e4962"/>
+    <p:sldMasterId xmlns:r="http://schemas.openxmlformats.org/officeDocument/2006/relationships" id="2147483648" r:id="Rbab965e4e0184c4e"/>
   </p:sldMasterIdLst>
   <p:notesMasterIdLst>
-    <p:notesMasterId xmlns:r="http://schemas.openxmlformats.org/officeDocument/2006/relationships" r:id="R2b8e095f144247ff"/>
+    <p:notesMasterId xmlns:r="http://schemas.openxmlformats.org/officeDocument/2006/relationships" r:id="Rf8679657ae994763"/>
   </p:notesMasterIdLst>
   <p:sldIdLst>
-    <p:sldId xmlns:r="http://schemas.openxmlformats.org/officeDocument/2006/relationships" id="256" r:id="Rc5129198af2b4530"/>
-    <p:sldId xmlns:r="http://schemas.openxmlformats.org/officeDocument/2006/relationships" id="257" r:id="Re9fd1f725be444f2"/>
-    <p:sldId xmlns:r="http://schemas.openxmlformats.org/officeDocument/2006/relationships" id="258" r:id="R0e5da1f8ecab490d"/>
-    <p:sldId xmlns:r="http://schemas.openxmlformats.org/officeDocument/2006/relationships" id="259" r:id="Rc3564f17f8b64fae"/>
-    <p:sldId xmlns:r="http://schemas.openxmlformats.org/officeDocument/2006/relationships" id="260" r:id="R2b70cef0916949a2"/>
-    <p:sldId xmlns:r="http://schemas.openxmlformats.org/officeDocument/2006/relationships" id="261" r:id="R4770aace0eaa4054"/>
-    <p:sldId xmlns:r="http://schemas.openxmlformats.org/officeDocument/2006/relationships" id="262" r:id="Rde530ce04983438b"/>
-    <p:sldId xmlns:r="http://schemas.openxmlformats.org/officeDocument/2006/relationships" id="263" r:id="R067068213269413d"/>
-    <p:sldId xmlns:r="http://schemas.openxmlformats.org/officeDocument/2006/relationships" id="264" r:id="Rb9c3228d616f4ad2"/>
-    <p:sldId xmlns:r="http://schemas.openxmlformats.org/officeDocument/2006/relationships" id="265" r:id="R99471f6b0b07409a"/>
-    <p:sldId xmlns:r="http://schemas.openxmlformats.org/officeDocument/2006/relationships" id="266" r:id="R523e46f4e75b4d8c"/>
+    <p:sldId xmlns:r="http://schemas.openxmlformats.org/officeDocument/2006/relationships" id="256" r:id="Rc54818f1902948b5"/>
+    <p:sldId xmlns:r="http://schemas.openxmlformats.org/officeDocument/2006/relationships" id="257" r:id="Rb2536e4a74b545a4"/>
+    <p:sldId xmlns:r="http://schemas.openxmlformats.org/officeDocument/2006/relationships" id="258" r:id="R69f855c4f2db4758"/>
+    <p:sldId xmlns:r="http://schemas.openxmlformats.org/officeDocument/2006/relationships" id="259" r:id="Rbdee7877b5bb48be"/>
+    <p:sldId xmlns:r="http://schemas.openxmlformats.org/officeDocument/2006/relationships" id="260" r:id="Raefbc9dd64ad4b91"/>
+    <p:sldId xmlns:r="http://schemas.openxmlformats.org/officeDocument/2006/relationships" id="261" r:id="R110d7b64944149a2"/>
+    <p:sldId xmlns:r="http://schemas.openxmlformats.org/officeDocument/2006/relationships" id="262" r:id="Rae72e2cf2cfd49ca"/>
+    <p:sldId xmlns:r="http://schemas.openxmlformats.org/officeDocument/2006/relationships" id="263" r:id="R0e0a7ccc1ce441ae"/>
+    <p:sldId xmlns:r="http://schemas.openxmlformats.org/officeDocument/2006/relationships" id="264" r:id="R4cbac13816d34c9a"/>
+    <p:sldId xmlns:r="http://schemas.openxmlformats.org/officeDocument/2006/relationships" id="265" r:id="R4889cfd5b45f426b"/>
+    <p:sldId xmlns:r="http://schemas.openxmlformats.org/officeDocument/2006/relationships" id="266" r:id="Re7305bdd50994aec"/>
   </p:sldIdLst>
   <p:sldSz cx="12192000" cy="6858000"/>
   <p:notesSz cx="6858000" cy="9144000"/>
@@ -470,6 +470,15 @@
               <a:t>- Boundary: current software and protocol evidence; no external performance claim.</a:t>
             </a:r>
           </a:p>
+          <a:p xmlns:a="http://schemas.openxmlformats.org/drawingml/2006/main">
+            <a:r>
+              <a:t>
+[Sources]
+- dashboard/proof_to_pilot.html
+- Internal product screenshot and workflow framing; no field-performance claim.
+</a:t>
+            </a:r>
+          </a:p>
         </p:txBody>
       </p:sp>
       <p:sp>
@@ -555,6 +564,15 @@
               <a:t>- No funding amount, valuation, dilution, or spend authorization is represented.</a:t>
             </a:r>
           </a:p>
+          <a:p xmlns:a="http://schemas.openxmlformats.org/drawingml/2006/main">
+            <a:r>
+              <a:t>
+[Sources]
+- code/ops/BUILD_SOURCE_NATIVE_RESEARCH_WHITEPAPER.py
+- Funding use is a proposed validation plan.
+</a:t>
+            </a:r>
+          </a:p>
         </p:txBody>
       </p:sp>
       <p:sp>
@@ -640,6 +658,15 @@
               <a:t>- The ask is for a bounded validation relationship, not an external performance claim.</a:t>
             </a:r>
           </a:p>
+          <a:p xmlns:a="http://schemas.openxmlformats.org/drawingml/2006/main">
+            <a:r>
+              <a:t>
+[Sources]
+- grant_submissions/funding_sprint_20260709/CURRENT_REVIEWER_FRONT_DOOR_2026-07-29.md
+- Bounded ask and human release controls.
+</a:t>
+            </a:r>
+          </a:p>
         </p:txBody>
       </p:sp>
       <p:sp>
@@ -725,6 +752,15 @@
               <a:t>- The trust-break framing is an internal operating hypothesis, not a market statistic.</a:t>
             </a:r>
           </a:p>
+          <a:p xmlns:a="http://schemas.openxmlformats.org/drawingml/2006/main">
+            <a:r>
+              <a:t>
+[Sources]
+- config/federal_reviewer_objection_register_v1.json
+- Internal evidence-gating problem definition.
+</a:t>
+            </a:r>
+          </a:p>
         </p:txBody>
       </p:sp>
       <p:sp>
@@ -805,6 +841,15 @@
               <a:t>- Local: out/ops/prooflock_opportunity_ops_pilot/latest/prooflock_opportunity_ops_pilot_definition.json</a:t>
             </a:r>
           </a:p>
+          <a:p xmlns:a="http://schemas.openxmlformats.org/drawingml/2006/main">
+            <a:r>
+              <a:t>
+[Sources]
+- config/noahs_proof_chain_v1.json
+- Internal freeze, replay, gate, and receipt workflow.
+</a:t>
+            </a:r>
+          </a:p>
         </p:txBody>
       </p:sp>
       <p:sp>
@@ -885,6 +930,15 @@
               <a:t>- Target sectors and buyer roles are positioning hypotheses; no customer adoption is claimed.</a:t>
             </a:r>
           </a:p>
+          <a:p xmlns:a="http://schemas.openxmlformats.org/drawingml/2006/main">
+            <a:r>
+              <a:t>
+[Sources]
+- code/ops/BUILD_FIRST_BUYER_TARGET_BOARD.py
+- Internal customer hypothesis; not market validation.
+</a:t>
+            </a:r>
+          </a:p>
         </p:txBody>
       </p:sp>
       <p:sp>
@@ -975,6 +1029,15 @@
               <a:t>- Local: out/ops/time_series_source_native_prospective_protocol_status.json</a:t>
             </a:r>
           </a:p>
+          <a:p xmlns:a="http://schemas.openxmlformats.org/drawingml/2006/main">
+            <a:r>
+              <a:t>
+[Sources]
+- out/ops/source_native_family_baseline_ledger_latest.json
+- out/ops/time_series_source_native_prospective_protocol_status.json
+</a:t>
+            </a:r>
+          </a:p>
         </p:txBody>
       </p:sp>
       <p:sp>
@@ -1055,6 +1118,15 @@
               <a:t>- Pricing is intentionally unquoted and requires buyer-specific founder approval.</a:t>
             </a:r>
           </a:p>
+          <a:p xmlns:a="http://schemas.openxmlformats.org/drawingml/2006/main">
+            <a:r>
+              <a:t>
+[Sources]
+- code/ops/BUILD_PROOF_TO_REVENUE_ENGINE.py
+- Proposed commercial path; not realized revenue.
+</a:t>
+            </a:r>
+          </a:p>
         </p:txBody>
       </p:sp>
       <p:sp>
@@ -1135,6 +1207,15 @@
               <a:t>- Competitive placement is a positioning hypothesis; no market share or superiority claim.</a:t>
             </a:r>
           </a:p>
+          <a:p xmlns:a="http://schemas.openxmlformats.org/drawingml/2006/main">
+            <a:r>
+              <a:t>
+[Sources]
+- code/ops/BUILD_INVESTOR_READY_BUSINESS_PLAN_20260703.py
+- Internal positioning hypothesis.
+</a:t>
+            </a:r>
+          </a:p>
         </p:txBody>
       </p:sp>
       <p:sp>
@@ -1215,6 +1296,15 @@
               <a:t>- Qualification gates are operating controls, not forecast conversion rates.</a:t>
             </a:r>
           </a:p>
+          <a:p xmlns:a="http://schemas.openxmlformats.org/drawingml/2006/main">
+            <a:r>
+              <a:t>
+[Sources]
+- code/ops/BUILD_FIRST_BUYER_TARGET_BOARD.py
+- Internal go-to-market sequence.
+</a:t>
+            </a:r>
+          </a:p>
         </p:txBody>
       </p:sp>
       <p:sp>
@@ -1293,6 +1383,15 @@
           <a:p xmlns:a="http://schemas.openxmlformats.org/drawingml/2006/main">
             <a:r>
               <a:t>- Local: out/ops/prooflock_opportunity_ops_pilot/latest/prooflock_opportunity_ops_pilot_definition.json</a:t>
+            </a:r>
+          </a:p>
+          <a:p xmlns:a="http://schemas.openxmlformats.org/drawingml/2006/main">
+            <a:r>
+              <a:t>
+[Sources]
+- code/ops/BUILD_FIELD_VALIDATION_BUYER_PILOT_PACKET.py
+- Proposed paid-pilot evidence contract.
+</a:t>
             </a:r>
           </a:p>
         </p:txBody>
@@ -1360,7 +1459,7 @@
   </p:cSld>
   <p:clrMap bg1="lt1" tx1="dk1" bg2="lt2" tx2="dk2" accent1="accent1" accent2="accent2" accent3="accent3" accent4="accent4" accent5="accent5" accent6="accent6" hlink="hlink" folHlink="folHlink"/>
   <p:sldLayoutIdLst>
-    <p:sldLayoutId xmlns:r="http://schemas.openxmlformats.org/officeDocument/2006/relationships" id="2147483649" r:id="R31d2c9ed55904d0a"/>
+    <p:sldLayoutId xmlns:r="http://schemas.openxmlformats.org/officeDocument/2006/relationships" id="2147483649" r:id="R4dee05ecfdb34ff9"/>
   </p:sldLayoutIdLst>
   <p:txStyles>
     <p:titleStyle>
@@ -2455,7 +2554,7 @@
           <p:nvPr/>
         </p:nvPicPr>
         <p:blipFill>
-          <a:blip xmlns:r="http://schemas.openxmlformats.org/officeDocument/2006/relationships" xmlns:a="http://schemas.openxmlformats.org/drawingml/2006/main" r:embed="R30bfbcfed2a246f7"/>
+          <a:blip xmlns:r="http://schemas.openxmlformats.org/officeDocument/2006/relationships" xmlns:a="http://schemas.openxmlformats.org/drawingml/2006/main" r:embed="Redb1926dcfd4486b"/>
           <a:srcRect xmlns:a="http://schemas.openxmlformats.org/drawingml/2006/main" l="0" t="0" r="0" b="0"/>
           <a:stretch xmlns:a="http://schemas.openxmlformats.org/drawingml/2006/main">
             <a:fillRect l="0" t="0" r="0" b="0"/>
@@ -8186,7 +8285,7 @@
       </p:sp>
       <p:cxnSp>
         <p:nvCxnSpPr>
-          <p:cNvPr id="63" name=""/>
+          <p:cNvPr id="99" name=""/>
           <p:cNvCxnSpPr>
             <a:stCxn xmlns:a="http://schemas.openxmlformats.org/drawingml/2006/main" id="6" idx="3"/>
             <a:endCxn xmlns:a="http://schemas.openxmlformats.org/drawingml/2006/main" id="7" idx="1"/>
@@ -8212,7 +8311,7 @@
       </p:cxnSp>
       <p:cxnSp>
         <p:nvCxnSpPr>
-          <p:cNvPr id="64" name=""/>
+          <p:cNvPr id="100" name=""/>
           <p:cNvCxnSpPr>
             <a:stCxn xmlns:a="http://schemas.openxmlformats.org/drawingml/2006/main" id="7" idx="3"/>
             <a:endCxn xmlns:a="http://schemas.openxmlformats.org/drawingml/2006/main" id="8" idx="1"/>
@@ -8238,7 +8337,7 @@
       </p:cxnSp>
       <p:cxnSp>
         <p:nvCxnSpPr>
-          <p:cNvPr id="65" name=""/>
+          <p:cNvPr id="101" name=""/>
           <p:cNvCxnSpPr>
             <a:stCxn xmlns:a="http://schemas.openxmlformats.org/drawingml/2006/main" id="8" idx="3"/>
             <a:endCxn xmlns:a="http://schemas.openxmlformats.org/drawingml/2006/main" id="9" idx="1"/>
@@ -11719,7 +11818,7 @@
                 <a:ea typeface="Aptos"/>
                 <a:cs typeface="Aptos"/>
               </a:rPr>
-              <a:t>120 direct comparisons across 22 candidate-source cards</a:t>
+              <a:t>126 direct comparisons across 23 candidate-source cards</a:t>
             </a:r>
           </a:p>
         </p:txBody>
@@ -16494,7 +16593,7 @@
       </p:sp>
       <p:cxnSp>
         <p:nvCxnSpPr>
-          <p:cNvPr id="56" name=""/>
+          <p:cNvPr id="86" name=""/>
           <p:cNvCxnSpPr>
             <a:stCxn xmlns:a="http://schemas.openxmlformats.org/drawingml/2006/main" id="6" idx="3"/>
             <a:endCxn xmlns:a="http://schemas.openxmlformats.org/drawingml/2006/main" id="7" idx="1"/>
@@ -16520,7 +16619,7 @@
       </p:cxnSp>
       <p:cxnSp>
         <p:nvCxnSpPr>
-          <p:cNvPr id="57" name=""/>
+          <p:cNvPr id="87" name=""/>
           <p:cNvCxnSpPr>
             <a:stCxn xmlns:a="http://schemas.openxmlformats.org/drawingml/2006/main" id="7" idx="3"/>
             <a:endCxn xmlns:a="http://schemas.openxmlformats.org/drawingml/2006/main" id="8" idx="1"/>

</xml_diff>

<commit_message>
Refresh governed reviewer artifacts
</commit_message>
<xml_diff>
--- a/output/pptx/LumenCore_Evidence_to_Pilot_Deck_CURRENT_REVIEW_REQUIRED.pptx
+++ b/output/pptx/LumenCore_Evidence_to_Pilot_Deck_CURRENT_REVIEW_REQUIRED.pptx
@@ -2,23 +2,23 @@
 <file path=ppt/presentation.xml><?xml version="1.0" encoding="utf-8"?>
 <p:presentation xmlns:p="http://schemas.openxmlformats.org/presentationml/2006/main">
   <p:sldMasterIdLst>
-    <p:sldMasterId xmlns:r="http://schemas.openxmlformats.org/officeDocument/2006/relationships" id="2147483648" r:id="Rbab965e4e0184c4e"/>
+    <p:sldMasterId xmlns:r="http://schemas.openxmlformats.org/officeDocument/2006/relationships" id="2147483648" r:id="R8bbf0951a39b426b"/>
   </p:sldMasterIdLst>
   <p:notesMasterIdLst>
-    <p:notesMasterId xmlns:r="http://schemas.openxmlformats.org/officeDocument/2006/relationships" r:id="Rf8679657ae994763"/>
+    <p:notesMasterId xmlns:r="http://schemas.openxmlformats.org/officeDocument/2006/relationships" r:id="R273e985b69c34b0a"/>
   </p:notesMasterIdLst>
   <p:sldIdLst>
-    <p:sldId xmlns:r="http://schemas.openxmlformats.org/officeDocument/2006/relationships" id="256" r:id="Rc54818f1902948b5"/>
-    <p:sldId xmlns:r="http://schemas.openxmlformats.org/officeDocument/2006/relationships" id="257" r:id="Rb2536e4a74b545a4"/>
-    <p:sldId xmlns:r="http://schemas.openxmlformats.org/officeDocument/2006/relationships" id="258" r:id="R69f855c4f2db4758"/>
-    <p:sldId xmlns:r="http://schemas.openxmlformats.org/officeDocument/2006/relationships" id="259" r:id="Rbdee7877b5bb48be"/>
-    <p:sldId xmlns:r="http://schemas.openxmlformats.org/officeDocument/2006/relationships" id="260" r:id="Raefbc9dd64ad4b91"/>
-    <p:sldId xmlns:r="http://schemas.openxmlformats.org/officeDocument/2006/relationships" id="261" r:id="R110d7b64944149a2"/>
-    <p:sldId xmlns:r="http://schemas.openxmlformats.org/officeDocument/2006/relationships" id="262" r:id="Rae72e2cf2cfd49ca"/>
-    <p:sldId xmlns:r="http://schemas.openxmlformats.org/officeDocument/2006/relationships" id="263" r:id="R0e0a7ccc1ce441ae"/>
-    <p:sldId xmlns:r="http://schemas.openxmlformats.org/officeDocument/2006/relationships" id="264" r:id="R4cbac13816d34c9a"/>
-    <p:sldId xmlns:r="http://schemas.openxmlformats.org/officeDocument/2006/relationships" id="265" r:id="R4889cfd5b45f426b"/>
-    <p:sldId xmlns:r="http://schemas.openxmlformats.org/officeDocument/2006/relationships" id="266" r:id="Re7305bdd50994aec"/>
+    <p:sldId xmlns:r="http://schemas.openxmlformats.org/officeDocument/2006/relationships" id="256" r:id="Rdadc57db2bca49eb"/>
+    <p:sldId xmlns:r="http://schemas.openxmlformats.org/officeDocument/2006/relationships" id="257" r:id="R7ac008c5da79495f"/>
+    <p:sldId xmlns:r="http://schemas.openxmlformats.org/officeDocument/2006/relationships" id="258" r:id="R97347453fcc247bb"/>
+    <p:sldId xmlns:r="http://schemas.openxmlformats.org/officeDocument/2006/relationships" id="259" r:id="R895529d74e6d47d7"/>
+    <p:sldId xmlns:r="http://schemas.openxmlformats.org/officeDocument/2006/relationships" id="260" r:id="R13906c2a4cca464d"/>
+    <p:sldId xmlns:r="http://schemas.openxmlformats.org/officeDocument/2006/relationships" id="261" r:id="R6a054ab133ed4f19"/>
+    <p:sldId xmlns:r="http://schemas.openxmlformats.org/officeDocument/2006/relationships" id="262" r:id="Ra329776b3e2243fc"/>
+    <p:sldId xmlns:r="http://schemas.openxmlformats.org/officeDocument/2006/relationships" id="263" r:id="R14b8cff6d57e4142"/>
+    <p:sldId xmlns:r="http://schemas.openxmlformats.org/officeDocument/2006/relationships" id="264" r:id="R3ca30f9d6d7f4d16"/>
+    <p:sldId xmlns:r="http://schemas.openxmlformats.org/officeDocument/2006/relationships" id="265" r:id="R2b2c2f7f152b49ae"/>
+    <p:sldId xmlns:r="http://schemas.openxmlformats.org/officeDocument/2006/relationships" id="266" r:id="R670ee68b72da4084"/>
   </p:sldIdLst>
   <p:sldSz cx="12192000" cy="6858000"/>
   <p:notesSz cx="6858000" cy="9144000"/>
@@ -1021,7 +1021,12 @@
           </a:p>
           <a:p xmlns:a="http://schemas.openxmlformats.org/drawingml/2006/main">
             <a:r>
-              <a:t>- Local: config/time_series_source_native_prospective_protocol_v1.json</a:t>
+              <a:t>- Local: config/time_series_source_native_prospective_protocol_v3.json</a:t>
+            </a:r>
+          </a:p>
+          <a:p xmlns:a="http://schemas.openxmlformats.org/drawingml/2006/main">
+            <a:r>
+              <a:t>- Local: docs/TIME_SERIES_SOURCE_NATIVE_PROSPECTIVE_CUSTODY_V3_2026-08-02.md</a:t>
             </a:r>
           </a:p>
           <a:p xmlns:a="http://schemas.openxmlformats.org/drawingml/2006/main">
@@ -1031,11 +1036,32 @@
           </a:p>
           <a:p xmlns:a="http://schemas.openxmlformats.org/drawingml/2006/main">
             <a:r>
-              <a:t>
-[Sources]
-- out/ops/source_native_family_baseline_ledger_latest.json
-- out/ops/time_series_source_native_prospective_protocol_status.json
-</a:t>
+              <a:t/>
+            </a:r>
+          </a:p>
+          <a:p xmlns:a="http://schemas.openxmlformats.org/drawingml/2006/main">
+            <a:r>
+              <a:t/>
+            </a:r>
+          </a:p>
+          <a:p xmlns:a="http://schemas.openxmlformats.org/drawingml/2006/main">
+            <a:r>
+              <a:t>[Sources]</a:t>
+            </a:r>
+          </a:p>
+          <a:p xmlns:a="http://schemas.openxmlformats.org/drawingml/2006/main">
+            <a:r>
+              <a:t>- out/ops/source_native_family_baseline_ledger_latest.json</a:t>
+            </a:r>
+          </a:p>
+          <a:p xmlns:a="http://schemas.openxmlformats.org/drawingml/2006/main">
+            <a:r>
+              <a:t>- out/ops/time_series_source_native_prospective_protocol_status.json</a:t>
+            </a:r>
+          </a:p>
+          <a:p xmlns:a="http://schemas.openxmlformats.org/drawingml/2006/main">
+            <a:r>
+              <a:t/>
             </a:r>
           </a:p>
         </p:txBody>
@@ -1459,7 +1485,7 @@
   </p:cSld>
   <p:clrMap bg1="lt1" tx1="dk1" bg2="lt2" tx2="dk2" accent1="accent1" accent2="accent2" accent3="accent3" accent4="accent4" accent5="accent5" accent6="accent6" hlink="hlink" folHlink="folHlink"/>
   <p:sldLayoutIdLst>
-    <p:sldLayoutId xmlns:r="http://schemas.openxmlformats.org/officeDocument/2006/relationships" id="2147483649" r:id="R4dee05ecfdb34ff9"/>
+    <p:sldLayoutId xmlns:r="http://schemas.openxmlformats.org/officeDocument/2006/relationships" id="2147483649" r:id="R5b8aa4566d1940c6"/>
   </p:sldLayoutIdLst>
   <p:txStyles>
     <p:titleStyle>
@@ -2554,7 +2580,7 @@
           <p:nvPr/>
         </p:nvPicPr>
         <p:blipFill>
-          <a:blip xmlns:r="http://schemas.openxmlformats.org/officeDocument/2006/relationships" xmlns:a="http://schemas.openxmlformats.org/drawingml/2006/main" r:embed="Redb1926dcfd4486b"/>
+          <a:blip xmlns:r="http://schemas.openxmlformats.org/officeDocument/2006/relationships" xmlns:a="http://schemas.openxmlformats.org/drawingml/2006/main" r:embed="R5ec5d3ce3d08432f"/>
           <a:srcRect xmlns:a="http://schemas.openxmlformats.org/drawingml/2006/main" l="0" t="0" r="0" b="0"/>
           <a:stretch xmlns:a="http://schemas.openxmlformats.org/drawingml/2006/main">
             <a:fillRect l="0" t="0" r="0" b="0"/>
@@ -2685,7 +2711,7 @@
                 <a:ea typeface="Aptos"/>
                 <a:cs typeface="Aptos"/>
               </a:rPr>
-              <a:t>LUMENCORE | EVIDENCE-TO-PILOT BRIEF | 2026-07-29</a:t>
+              <a:t>LUMENCORE | EVIDENCE-TO-PILOT BRIEF | 2026-08-02</a:t>
             </a:r>
           </a:p>
         </p:txBody>
@@ -4744,7 +4770,7 @@
                 <a:ea typeface="Aptos"/>
                 <a:cs typeface="Aptos"/>
               </a:rPr>
-              <a:t>LUMENCORE | EVIDENCE-TO-PILOT BRIEF | 2026-07-29</a:t>
+              <a:t>LUMENCORE | EVIDENCE-TO-PILOT BRIEF | 2026-08-02</a:t>
             </a:r>
           </a:p>
         </p:txBody>
@@ -5908,7 +5934,7 @@
                 <a:ea typeface="Aptos"/>
                 <a:cs typeface="Aptos"/>
               </a:rPr>
-              <a:t>LUMENCORE | EVIDENCE-TO-PILOT BRIEF | 2026-07-29</a:t>
+              <a:t>LUMENCORE | EVIDENCE-TO-PILOT BRIEF | 2026-08-02</a:t>
             </a:r>
           </a:p>
         </p:txBody>
@@ -7781,7 +7807,7 @@
                 <a:ea typeface="Aptos"/>
                 <a:cs typeface="Aptos"/>
               </a:rPr>
-              <a:t>LUMENCORE | EVIDENCE-TO-PILOT BRIEF | 2026-07-29</a:t>
+              <a:t>LUMENCORE | EVIDENCE-TO-PILOT BRIEF | 2026-08-02</a:t>
             </a:r>
           </a:p>
         </p:txBody>
@@ -8285,7 +8311,7 @@
       </p:sp>
       <p:cxnSp>
         <p:nvCxnSpPr>
-          <p:cNvPr id="99" name=""/>
+          <p:cNvPr id="123" name=""/>
           <p:cNvCxnSpPr>
             <a:stCxn xmlns:a="http://schemas.openxmlformats.org/drawingml/2006/main" id="6" idx="3"/>
             <a:endCxn xmlns:a="http://schemas.openxmlformats.org/drawingml/2006/main" id="7" idx="1"/>
@@ -8311,7 +8337,7 @@
       </p:cxnSp>
       <p:cxnSp>
         <p:nvCxnSpPr>
-          <p:cNvPr id="100" name=""/>
+          <p:cNvPr id="124" name=""/>
           <p:cNvCxnSpPr>
             <a:stCxn xmlns:a="http://schemas.openxmlformats.org/drawingml/2006/main" id="7" idx="3"/>
             <a:endCxn xmlns:a="http://schemas.openxmlformats.org/drawingml/2006/main" id="8" idx="1"/>
@@ -8337,7 +8363,7 @@
       </p:cxnSp>
       <p:cxnSp>
         <p:nvCxnSpPr>
-          <p:cNvPr id="101" name=""/>
+          <p:cNvPr id="125" name=""/>
           <p:cNvCxnSpPr>
             <a:stCxn xmlns:a="http://schemas.openxmlformats.org/drawingml/2006/main" id="8" idx="3"/>
             <a:endCxn xmlns:a="http://schemas.openxmlformats.org/drawingml/2006/main" id="9" idx="1"/>
@@ -9276,7 +9302,7 @@
                 <a:ea typeface="Aptos"/>
                 <a:cs typeface="Aptos"/>
               </a:rPr>
-              <a:t>LUMENCORE | EVIDENCE-TO-PILOT BRIEF | 2026-07-29</a:t>
+              <a:t>LUMENCORE | EVIDENCE-TO-PILOT BRIEF | 2026-08-02</a:t>
             </a:r>
           </a:p>
         </p:txBody>
@@ -11030,7 +11056,7 @@
                 <a:ea typeface="Aptos"/>
                 <a:cs typeface="Aptos"/>
               </a:rPr>
-              <a:t>LUMENCORE | EVIDENCE-TO-PILOT BRIEF | 2026-07-29</a:t>
+              <a:t>LUMENCORE | EVIDENCE-TO-PILOT BRIEF | 2026-08-02</a:t>
             </a:r>
           </a:p>
         </p:txBody>
@@ -13030,7 +13056,7 @@
                 <a:ea typeface="Aptos"/>
                 <a:cs typeface="Aptos"/>
               </a:rPr>
-              <a:t>Protocol LUMENCORE_TS_SOURCE_NATIVE_20260729_V1 is frozen and waiting for new source rows.</a:t>
+              <a:t>V3 protocol LUMENCORE_TS_SOURCE_NATIVE_20260802_V3 is sealed and awaiting future observations.</a:t>
             </a:r>
           </a:p>
         </p:txBody>
@@ -13089,7 +13115,7 @@
                 <a:ea typeface="Aptos"/>
                 <a:cs typeface="Aptos"/>
               </a:rPr>
-              <a:t>LUMENCORE | EVIDENCE-TO-PILOT BRIEF | 2026-07-29</a:t>
+              <a:t>LUMENCORE | EVIDENCE-TO-PILOT BRIEF | 2026-08-02</a:t>
             </a:r>
           </a:p>
         </p:txBody>
@@ -14548,7 +14574,7 @@
                 <a:ea typeface="Aptos"/>
                 <a:cs typeface="Aptos"/>
               </a:rPr>
-              <a:t>LUMENCORE | EVIDENCE-TO-PILOT BRIEF | 2026-07-29</a:t>
+              <a:t>LUMENCORE | EVIDENCE-TO-PILOT BRIEF | 2026-08-02</a:t>
             </a:r>
           </a:p>
         </p:txBody>
@@ -15176,8 +15202,8 @@
         </p:nvSpPr>
         <p:spPr>
           <a:xfrm xmlns:a="http://schemas.openxmlformats.org/drawingml/2006/main">
-            <a:off x="695325" y="2705100"/>
-            <a:ext cx="571500" cy="666750"/>
+            <a:off x="314325" y="2705100"/>
+            <a:ext cx="952500" cy="666750"/>
           </a:xfrm>
           <a:prstGeom xmlns:a="http://schemas.openxmlformats.org/drawingml/2006/main" prst="rect">
             <a:avLst/>
@@ -16124,7 +16150,7 @@
                 <a:ea typeface="Aptos"/>
                 <a:cs typeface="Aptos"/>
               </a:rPr>
-              <a:t>LUMENCORE | EVIDENCE-TO-PILOT BRIEF | 2026-07-29</a:t>
+              <a:t>LUMENCORE | EVIDENCE-TO-PILOT BRIEF | 2026-08-02</a:t>
             </a:r>
           </a:p>
         </p:txBody>
@@ -16593,7 +16619,7 @@
       </p:sp>
       <p:cxnSp>
         <p:nvCxnSpPr>
-          <p:cNvPr id="86" name=""/>
+          <p:cNvPr id="106" name=""/>
           <p:cNvCxnSpPr>
             <a:stCxn xmlns:a="http://schemas.openxmlformats.org/drawingml/2006/main" id="6" idx="3"/>
             <a:endCxn xmlns:a="http://schemas.openxmlformats.org/drawingml/2006/main" id="7" idx="1"/>
@@ -16619,7 +16645,7 @@
       </p:cxnSp>
       <p:cxnSp>
         <p:nvCxnSpPr>
-          <p:cNvPr id="87" name=""/>
+          <p:cNvPr id="107" name=""/>
           <p:cNvCxnSpPr>
             <a:stCxn xmlns:a="http://schemas.openxmlformats.org/drawingml/2006/main" id="7" idx="3"/>
             <a:endCxn xmlns:a="http://schemas.openxmlformats.org/drawingml/2006/main" id="8" idx="1"/>
@@ -17558,7 +17584,7 @@
                 <a:ea typeface="Aptos"/>
                 <a:cs typeface="Aptos"/>
               </a:rPr>
-              <a:t>LUMENCORE | EVIDENCE-TO-PILOT BRIEF | 2026-07-29</a:t>
+              <a:t>LUMENCORE | EVIDENCE-TO-PILOT BRIEF | 2026-08-02</a:t>
             </a:r>
           </a:p>
         </p:txBody>
@@ -19617,7 +19643,7 @@
                 <a:ea typeface="Aptos"/>
                 <a:cs typeface="Aptos"/>
               </a:rPr>
-              <a:t>LUMENCORE | EVIDENCE-TO-PILOT BRIEF | 2026-07-29</a:t>
+              <a:t>LUMENCORE | EVIDENCE-TO-PILOT BRIEF | 2026-08-02</a:t>
             </a:r>
           </a:p>
         </p:txBody>

</xml_diff>